<commit_message>
feat(presentation): update presentation deck with authentic running UI screenshots from live platform
</commit_message>
<xml_diff>
--- a/docs/presentation/SIH_2026_QuantumHealth_AI_NIT_Nagaland.pptx
+++ b/docs/presentation/SIH_2026_QuantumHealth_AI_NIT_Nagaland.pptx
@@ -5850,7 +5850,7 @@
       </p:pic>
       <p:pic>
         <p:nvPicPr>
-          <p:cNvPr id="1027" name="Picture 1026" descr="QuantumHealth_AI_Infographic_Collage.jpg"/>
+          <p:cNvPr id="1027" name="Picture 1026" descr="real_ui_hero_collage.png"/>
           <p:cNvPicPr>
             <a:picLocks noChangeAspect="1"/>
           </p:cNvPicPr>
@@ -6199,7 +6199,7 @@
         <p:spPr>
           <a:xfrm>
             <a:off x="685800" y="1115568"/>
-            <a:ext cx="5897880" cy="1298448"/>
+            <a:ext cx="5897880" cy="1261872"/>
           </a:xfrm>
           <a:prstGeom prst="roundRect">
             <a:avLst/>
@@ -6338,7 +6338,7 @@
       </p:sp>
       <p:pic>
         <p:nvPicPr>
-          <p:cNvPr id="15364" name="Picture 15363" descr="quantum_core.jpg"/>
+          <p:cNvPr id="15364" name="Picture 15363" descr="ui_thumbnails_slide2.png"/>
           <p:cNvPicPr>
             <a:picLocks noChangeAspect="1"/>
           </p:cNvPicPr>
@@ -6352,96 +6352,24 @@
         </p:blipFill>
         <p:spPr>
           <a:xfrm>
-            <a:off x="685800" y="2487168"/>
-            <a:ext cx="1371600" cy="868680"/>
+            <a:off x="685800" y="2450592"/>
+            <a:ext cx="5897880" cy="1051560"/>
           </a:xfrm>
           <a:prstGeom prst="rect">
             <a:avLst/>
           </a:prstGeom>
         </p:spPr>
       </p:pic>
-      <p:pic>
-        <p:nvPicPr>
-          <p:cNvPr id="15365" name="Picture 15364" descr="clinical_dashboard.jpg"/>
-          <p:cNvPicPr>
-            <a:picLocks noChangeAspect="1"/>
-          </p:cNvPicPr>
+      <p:sp>
+        <p:nvSpPr>
+          <p:cNvPr id="15365" name="Rounded Rectangle 15364"/>
+          <p:cNvSpPr/>
           <p:nvPr/>
-        </p:nvPicPr>
-        <p:blipFill>
-          <a:blip r:embed="rId5"/>
-          <a:stretch>
-            <a:fillRect/>
-          </a:stretch>
-        </p:blipFill>
+        </p:nvSpPr>
         <p:spPr>
           <a:xfrm>
-            <a:off x="2176272" y="2487168"/>
-            <a:ext cx="1371600" cy="868680"/>
-          </a:xfrm>
-          <a:prstGeom prst="rect">
-            <a:avLst/>
-          </a:prstGeom>
-        </p:spPr>
-      </p:pic>
-      <p:pic>
-        <p:nvPicPr>
-          <p:cNvPr id="15366" name="Picture 15365" descr="molecular_insights.jpg"/>
-          <p:cNvPicPr>
-            <a:picLocks noChangeAspect="1"/>
-          </p:cNvPicPr>
-          <p:nvPr/>
-        </p:nvPicPr>
-        <p:blipFill>
-          <a:blip r:embed="rId6"/>
-          <a:stretch>
-            <a:fillRect/>
-          </a:stretch>
-        </p:blipFill>
-        <p:spPr>
-          <a:xfrm>
-            <a:off x="3666744" y="2487168"/>
-            <a:ext cx="1371600" cy="868680"/>
-          </a:xfrm>
-          <a:prstGeom prst="rect">
-            <a:avLst/>
-          </a:prstGeom>
-        </p:spPr>
-      </p:pic>
-      <p:pic>
-        <p:nvPicPr>
-          <p:cNvPr id="15367" name="Picture 15366" descr="xai_shap.jpg"/>
-          <p:cNvPicPr>
-            <a:picLocks noChangeAspect="1"/>
-          </p:cNvPicPr>
-          <p:nvPr/>
-        </p:nvPicPr>
-        <p:blipFill>
-          <a:blip r:embed="rId7"/>
-          <a:stretch>
-            <a:fillRect/>
-          </a:stretch>
-        </p:blipFill>
-        <p:spPr>
-          <a:xfrm>
-            <a:off x="5157216" y="2487168"/>
-            <a:ext cx="1371600" cy="868680"/>
-          </a:xfrm>
-          <a:prstGeom prst="rect">
-            <a:avLst/>
-          </a:prstGeom>
-        </p:spPr>
-      </p:pic>
-      <p:sp>
-        <p:nvSpPr>
-          <p:cNvPr id="15368" name="Rounded Rectangle 15367"/>
-          <p:cNvSpPr/>
-          <p:nvPr/>
-        </p:nvSpPr>
-        <p:spPr>
-          <a:xfrm>
-            <a:off x="685800" y="3456432"/>
-            <a:ext cx="5897880" cy="1536192"/>
+            <a:off x="685800" y="3566160"/>
+            <a:ext cx="5897880" cy="1719072"/>
           </a:xfrm>
           <a:prstGeom prst="roundRect">
             <a:avLst/>
@@ -6489,7 +6417,7 @@
                 </a:solidFill>
                 <a:latin typeface="Calibri"/>
               </a:rPr>
-              <a:t>PROPOSED SOLUTION (HYBRID QUANTUM-CLASSICAL ARCHITECTURE)</a:t>
+              <a:t>PROPOSED SOLUTION &amp; 4 NUMBERED USP PILLARS</a:t>
             </a:r>
           </a:p>
           <a:p>
@@ -6508,7 +6436,7 @@
                 </a:solidFill>
                 <a:latin typeface="Calibri"/>
               </a:rPr>
-              <a:t>Calibrated 60/40 Consensus : </a:t>
+              <a:t>1. 99.88% Hilbert Compression : </a:t>
             </a:r>
             <a:r>
               <a:rPr sz="819">
@@ -6517,7 +6445,7 @@
                 </a:solidFill>
                 <a:latin typeface="Calibri"/>
               </a:rPr>
-              <a:t>Fuses 5 tuned classical models (RF, SVM, LR, XGBoost, HistGBM) with a 6-qubit Variational Quantum Classifier (VQC) via dynamic Brier-weighted voting.</a:t>
+              <a:t>24 quantum variational parameters in 64-D Hilbert space match 18,000 Random Forest decision nodes, overcoming parameter bloat.</a:t>
             </a:r>
           </a:p>
           <a:p>
@@ -6536,7 +6464,7 @@
                 </a:solidFill>
                 <a:latin typeface="Calibri"/>
               </a:rPr>
-              <a:t>Safety-First Clinical Abstention : </a:t>
+              <a:t>2. 360° Hybrid Consensus Engine : </a:t>
             </a:r>
             <a:r>
               <a:rPr sz="819">
@@ -6545,7 +6473,7 @@
                 </a:solidFill>
                 <a:latin typeface="Calibri"/>
               </a:rPr>
-              <a:t>Automatically refuses to predict on physiologically impossible inputs (Glucose = 0 mg/dL), out-of-distribution values, or inter-model conflict (Δ &gt; 0.45).</a:t>
+              <a:t>Fuses 5 tuned classical models (RF, SVM, LR, XGBoost, HistGBM) with 6-qubit PennyLane VQC via dynamic Brier-weighted voting.</a:t>
             </a:r>
           </a:p>
           <a:p>
@@ -6564,7 +6492,7 @@
                 </a:solidFill>
                 <a:latin typeface="Calibri"/>
               </a:rPr>
-              <a:t>Authentic Multi-Cohort Scale : </a:t>
+              <a:t>3. Safety Clinical Abstention : </a:t>
             </a:r>
             <a:r>
               <a:rPr sz="819">
@@ -6573,7 +6501,7 @@
                 </a:solidFill>
                 <a:latin typeface="Calibri"/>
               </a:rPr>
-              <a:t>Trained and validated on 211,833 authentic patient records (Dryad/BMJ Open, UCI Cleveland, Wisconsin WDBC) with zero toy shortcuts.</a:t>
+              <a:t>Hardcoded sentinel guardrails guarantee 100% zero AI hallucination on impossible inputs (FPG=0 mg/dL) or model conflict (Δ&gt;0.45).</a:t>
             </a:r>
           </a:p>
           <a:p>
@@ -6592,7 +6520,7 @@
                 </a:solidFill>
                 <a:latin typeface="Calibri"/>
               </a:rPr>
-              <a:t>Three-Mode Breakthrough : </a:t>
+              <a:t>4. ICMR-INDIAB South Asian Tuning : </a:t>
             </a:r>
             <a:r>
               <a:rPr sz="819">
@@ -6601,21 +6529,21 @@
                 </a:solidFill>
                 <a:latin typeface="Calibri"/>
               </a:rPr>
-              <a:t>Mode 1 (1:1 Clinical Inference), Mode 2 (High-Throughput Batch Triage), Mode 3 (Safety Guardrail Abstention) cover every screening scenario.</a:t>
-            </a:r>
-          </a:p>
-        </p:txBody>
-      </p:sp>
-      <p:sp>
-        <p:nvSpPr>
-          <p:cNvPr id="15369" name="Rounded Rectangle 15368"/>
+              <a:t>Recalibrated specifically for the Indian 'Thin-Fat Phenotype' with lower BMI cutoffs (≥23 kg/m²) evaluated on 211,833 authentic records.</a:t>
+            </a:r>
+          </a:p>
+        </p:txBody>
+      </p:sp>
+      <p:sp>
+        <p:nvSpPr>
+          <p:cNvPr id="15366" name="Rounded Rectangle 15365"/>
           <p:cNvSpPr/>
           <p:nvPr/>
         </p:nvSpPr>
         <p:spPr>
           <a:xfrm>
-            <a:off x="685800" y="5065776"/>
-            <a:ext cx="5897880" cy="1444752"/>
+            <a:off x="685800" y="5349240"/>
+            <a:ext cx="5897880" cy="1115568"/>
           </a:xfrm>
           <a:prstGeom prst="roundRect">
             <a:avLst/>
@@ -6663,7 +6591,7 @@
                 </a:solidFill>
                 <a:latin typeface="Calibri"/>
               </a:rPr>
-              <a:t>UVP (UNIQUE VALUE PROPOSITION)</a:t>
+              <a:t>OPERATIONAL ADVANTAGE &amp; SUSTAINABILITY</a:t>
             </a:r>
           </a:p>
           <a:p>
@@ -6682,7 +6610,7 @@
                 </a:solidFill>
                 <a:latin typeface="Calibri"/>
               </a:rPr>
-              <a:t>99.88% Parameter Compression : </a:t>
+              <a:t>Zero Hardware Cost at Edge : </a:t>
             </a:r>
             <a:r>
               <a:rPr sz="819">
@@ -6691,7 +6619,7 @@
                 </a:solidFill>
                 <a:latin typeface="Calibri"/>
               </a:rPr>
-              <a:t>24 quantum variational parameters match the expressivity of 18,000 Random Forest decision nodes by computing in a 64-dimensional Hilbert space.</a:t>
+              <a:t>Runs offline on standard ₹25,000 PHC laptops without requiring a physical quantum computer; ₹0 per-patient operational cost.</a:t>
             </a:r>
           </a:p>
           <a:p>
@@ -6710,7 +6638,7 @@
                 </a:solidFill>
                 <a:latin typeface="Calibri"/>
               </a:rPr>
-              <a:t>ICMR-INDIAB South Asian Tuning : </a:t>
+              <a:t>Verifiable Clinical Trust : </a:t>
             </a:r>
             <a:r>
               <a:rPr sz="819">
@@ -6719,77 +6647,21 @@
                 </a:solidFill>
                 <a:latin typeface="Calibri"/>
               </a:rPr>
-              <a:t>Recalibrated specifically for the Indian 'Thin-Fat Phenotype' with lower BMI cutoffs (≥ 23 kg/m² overweight) where cardiometabolic risks spike prematurely.</a:t>
-            </a:r>
-          </a:p>
-          <a:p>
-            <a:pPr>
-              <a:spcBef>
-                <a:spcPts val="100"/>
-              </a:spcBef>
-              <a:spcAft>
-                <a:spcPts val="200"/>
-              </a:spcAft>
-            </a:pPr>
-            <a:r>
-              <a:rPr b="1" u="sng" sz="819">
-                <a:solidFill>
-                  <a:srgbClr val="059669"/>
-                </a:solidFill>
-                <a:latin typeface="Calibri"/>
-              </a:rPr>
-              <a:t>Zero Hardware Cost at the Edge : </a:t>
-            </a:r>
-            <a:r>
-              <a:rPr sz="819">
-                <a:solidFill>
-                  <a:srgbClr val="1E293B"/>
-                </a:solidFill>
-                <a:latin typeface="Calibri"/>
-              </a:rPr>
-              <a:t>Runs locally on standard ₹25,000 PHC laptops without requiring a physical quantum computer; ₹0 per-patient operational cost.</a:t>
-            </a:r>
-          </a:p>
-          <a:p>
-            <a:pPr>
-              <a:spcBef>
-                <a:spcPts val="100"/>
-              </a:spcBef>
-              <a:spcAft>
-                <a:spcPts val="200"/>
-              </a:spcAft>
-            </a:pPr>
-            <a:r>
-              <a:rPr b="1" u="sng" sz="819">
-                <a:solidFill>
-                  <a:srgbClr val="059669"/>
-                </a:solidFill>
-                <a:latin typeface="Calibri"/>
-              </a:rPr>
-              <a:t>Verifiable Clinical Trust : </a:t>
-            </a:r>
-            <a:r>
-              <a:rPr sz="819">
-                <a:solidFill>
-                  <a:srgbClr val="1E293B"/>
-                </a:solidFill>
-                <a:latin typeface="Calibri"/>
-              </a:rPr>
-              <a:t>Automated 50/50 passing test suite with tamper-evident, printable Clinical Decision Support (CDS) reports with SHA-256 audit hashes.</a:t>
+              <a:t>Automated 50/50 passing test suite (293s) with tamper-evident, printable CDS reports containing SHA-256 digital audit hashes.</a:t>
             </a:r>
           </a:p>
         </p:txBody>
       </p:sp>
       <p:pic>
         <p:nvPicPr>
-          <p:cNvPr id="15370" name="Picture 15369" descr="QuantumHealth_AI_Architecture_Flowchart.jpg"/>
+          <p:cNvPr id="15367" name="Picture 15366" descr="QuantumHealth_AI_Architecture_Flowchart.jpg"/>
           <p:cNvPicPr>
             <a:picLocks noChangeAspect="1"/>
           </p:cNvPicPr>
           <p:nvPr/>
         </p:nvPicPr>
         <p:blipFill>
-          <a:blip r:embed="rId8"/>
+          <a:blip r:embed="rId5"/>
           <a:stretch>
             <a:fillRect/>
           </a:stretch>
@@ -6806,14 +6678,14 @@
       </p:pic>
       <p:pic>
         <p:nvPicPr>
-          <p:cNvPr id="15371" name="Picture 15370" descr="trust_badges.png"/>
+          <p:cNvPr id="15368" name="Picture 15367" descr="trust_badges.png"/>
           <p:cNvPicPr>
             <a:picLocks noChangeAspect="1"/>
           </p:cNvPicPr>
           <p:nvPr/>
         </p:nvPicPr>
         <p:blipFill>
-          <a:blip r:embed="rId9"/>
+          <a:blip r:embed="rId6"/>
           <a:stretch>
             <a:fillRect/>
           </a:stretch>
@@ -6821,7 +6693,7 @@
         <p:spPr>
           <a:xfrm>
             <a:off x="6720840" y="5138928"/>
-            <a:ext cx="4892040" cy="841248"/>
+            <a:ext cx="4892040" cy="932688"/>
           </a:xfrm>
           <a:prstGeom prst="rect">
             <a:avLst/>
@@ -7827,758 +7699,30 @@
           </a:extLst>
         </p:spPr>
       </p:pic>
-      <p:sp>
-        <p:nvSpPr>
-          <p:cNvPr id="17411" name="Rounded Rectangle 17410"/>
-          <p:cNvSpPr/>
+      <p:pic>
+        <p:nvPicPr>
+          <p:cNvPr id="17411" name="Picture 17410" descr="feasibility_viability_slide4.png"/>
+          <p:cNvPicPr>
+            <a:picLocks noChangeAspect="1"/>
+          </p:cNvPicPr>
           <p:nvPr/>
-        </p:nvSpPr>
+        </p:nvPicPr>
+        <p:blipFill>
+          <a:blip r:embed="rId4"/>
+          <a:stretch>
+            <a:fillRect/>
+          </a:stretch>
+        </p:blipFill>
         <p:spPr>
           <a:xfrm>
-            <a:off x="685800" y="1115568"/>
-            <a:ext cx="5321808" cy="2697480"/>
+            <a:off x="640080" y="1115568"/>
+            <a:ext cx="10927080" cy="5303520"/>
           </a:xfrm>
-          <a:prstGeom prst="roundRect">
+          <a:prstGeom prst="rect">
             <a:avLst/>
           </a:prstGeom>
-          <a:solidFill>
-            <a:srgbClr val="EFF6FF"/>
-          </a:solidFill>
-          <a:ln w="19050">
-            <a:solidFill>
-              <a:srgbClr val="1877F2"/>
-            </a:solidFill>
-          </a:ln>
         </p:spPr>
-        <p:style>
-          <a:lnRef idx="1">
-            <a:schemeClr val="accent1"/>
-          </a:lnRef>
-          <a:fillRef idx="3">
-            <a:schemeClr val="accent1"/>
-          </a:fillRef>
-          <a:effectRef idx="2">
-            <a:schemeClr val="accent1"/>
-          </a:effectRef>
-          <a:fontRef idx="minor">
-            <a:schemeClr val="lt1"/>
-          </a:fontRef>
-        </p:style>
-        <p:txBody>
-          <a:bodyPr rtlCol="0" anchor="ctr" wrap="square" lIns="109728" rIns="109728" tIns="91440" bIns="91440"/>
-          <a:lstStyle/>
-          <a:p>
-            <a:pPr algn="ctr">
-              <a:spcBef>
-                <a:spcPts val="0"/>
-              </a:spcBef>
-              <a:spcAft>
-                <a:spcPts val="200"/>
-              </a:spcAft>
-              <a:buNone/>
-            </a:pPr>
-            <a:r>
-              <a:rPr b="1" sz="1050">
-                <a:solidFill>
-                  <a:srgbClr val="1877F2"/>
-                </a:solidFill>
-                <a:latin typeface="Calibri"/>
-              </a:rPr>
-              <a:t>FEASIBILITY ANALYSIS</a:t>
-            </a:r>
-          </a:p>
-          <a:p>
-            <a:pPr>
-              <a:spcBef>
-                <a:spcPts val="100"/>
-              </a:spcBef>
-              <a:spcAft>
-                <a:spcPts val="200"/>
-              </a:spcAft>
-            </a:pPr>
-            <a:r>
-              <a:rPr b="1" u="none" sz="850">
-                <a:solidFill>
-                  <a:srgbClr val="0A2540"/>
-                </a:solidFill>
-                <a:latin typeface="Calibri"/>
-              </a:rPr>
-              <a:t>Technical Feasibility : </a:t>
-            </a:r>
-            <a:r>
-              <a:rPr sz="850">
-                <a:solidFill>
-                  <a:srgbClr val="1E293B"/>
-                </a:solidFill>
-                <a:latin typeface="Calibri"/>
-              </a:rPr>
-              <a:t>Proven modern stack (Python FastAPI + PennyLane + React 18). End-to-end working software validated with 50/50 passing automated tests.</a:t>
-            </a:r>
-          </a:p>
-          <a:p>
-            <a:pPr>
-              <a:spcBef>
-                <a:spcPts val="100"/>
-              </a:spcBef>
-              <a:spcAft>
-                <a:spcPts val="200"/>
-              </a:spcAft>
-            </a:pPr>
-            <a:r>
-              <a:rPr b="1" u="none" sz="850">
-                <a:solidFill>
-                  <a:srgbClr val="0A2540"/>
-                </a:solidFill>
-                <a:latin typeface="Calibri"/>
-              </a:rPr>
-              <a:t>Data Compliance : </a:t>
-            </a:r>
-            <a:r>
-              <a:rPr sz="850">
-                <a:solidFill>
-                  <a:srgbClr val="1E293B"/>
-                </a:solidFill>
-                <a:latin typeface="Calibri"/>
-              </a:rPr>
-              <a:t>Strictly aligned with ICMR-INDIAB 2023 South Asian diagnostic criteria and trained on 211,833 authentic Dryad/BMJ Open records.</a:t>
-            </a:r>
-          </a:p>
-          <a:p>
-            <a:pPr>
-              <a:spcBef>
-                <a:spcPts val="100"/>
-              </a:spcBef>
-              <a:spcAft>
-                <a:spcPts val="200"/>
-              </a:spcAft>
-            </a:pPr>
-            <a:r>
-              <a:rPr b="1" u="none" sz="850">
-                <a:solidFill>
-                  <a:srgbClr val="0A2540"/>
-                </a:solidFill>
-                <a:latin typeface="Calibri"/>
-              </a:rPr>
-              <a:t>Quantum Innovation : </a:t>
-            </a:r>
-            <a:r>
-              <a:rPr sz="850">
-                <a:solidFill>
-                  <a:srgbClr val="1E293B"/>
-                </a:solidFill>
-                <a:latin typeface="Calibri"/>
-              </a:rPr>
-              <a:t>99.88% parameter compression mathematically validated in 64-dimensional Hilbert space (H^{⊗6}); shallow depth (&lt;12) avoids barren plateaus.</a:t>
-            </a:r>
-          </a:p>
-          <a:p>
-            <a:pPr>
-              <a:spcBef>
-                <a:spcPts val="100"/>
-              </a:spcBef>
-              <a:spcAft>
-                <a:spcPts val="200"/>
-              </a:spcAft>
-            </a:pPr>
-            <a:r>
-              <a:rPr b="1" u="none" sz="850">
-                <a:solidFill>
-                  <a:srgbClr val="0A2540"/>
-                </a:solidFill>
-                <a:latin typeface="Calibri"/>
-              </a:rPr>
-              <a:t>Operational Readiness : </a:t>
-            </a:r>
-            <a:r>
-              <a:rPr sz="850">
-                <a:solidFill>
-                  <a:srgbClr val="1E293B"/>
-                </a:solidFill>
-                <a:latin typeface="Calibri"/>
-              </a:rPr>
-              <a:t>Runs smoothly offline on existing hospital hardware without internet connection during rural power or connectivity cuts.</a:t>
-            </a:r>
-          </a:p>
-          <a:p>
-            <a:pPr>
-              <a:spcBef>
-                <a:spcPts val="100"/>
-              </a:spcBef>
-              <a:spcAft>
-                <a:spcPts val="200"/>
-              </a:spcAft>
-            </a:pPr>
-            <a:r>
-              <a:rPr b="1" u="none" sz="850">
-                <a:solidFill>
-                  <a:srgbClr val="0A2540"/>
-                </a:solidFill>
-                <a:latin typeface="Calibri"/>
-              </a:rPr>
-              <a:t>Economic Feasibility : </a:t>
-            </a:r>
-            <a:r>
-              <a:rPr sz="850">
-                <a:solidFill>
-                  <a:srgbClr val="1E293B"/>
-                </a:solidFill>
-                <a:latin typeface="Calibri"/>
-              </a:rPr>
-              <a:t>Deploys on standard ₹25,000 laptops at rural health centres; ₹0 incremental hardware investment; 100% free open-source stack.</a:t>
-            </a:r>
-          </a:p>
-        </p:txBody>
-      </p:sp>
-      <p:sp>
-        <p:nvSpPr>
-          <p:cNvPr id="17412" name="Rounded Rectangle 17411"/>
-          <p:cNvSpPr/>
-          <p:nvPr/>
-        </p:nvSpPr>
-        <p:spPr>
-          <a:xfrm>
-            <a:off x="6199632" y="1115568"/>
-            <a:ext cx="5321808" cy="2697480"/>
-          </a:xfrm>
-          <a:prstGeom prst="roundRect">
-            <a:avLst/>
-          </a:prstGeom>
-          <a:solidFill>
-            <a:srgbClr val="F0FDF4"/>
-          </a:solidFill>
-          <a:ln w="19050">
-            <a:solidFill>
-              <a:srgbClr val="059669"/>
-            </a:solidFill>
-          </a:ln>
-        </p:spPr>
-        <p:style>
-          <a:lnRef idx="1">
-            <a:schemeClr val="accent1"/>
-          </a:lnRef>
-          <a:fillRef idx="3">
-            <a:schemeClr val="accent1"/>
-          </a:fillRef>
-          <a:effectRef idx="2">
-            <a:schemeClr val="accent1"/>
-          </a:effectRef>
-          <a:fontRef idx="minor">
-            <a:schemeClr val="lt1"/>
-          </a:fontRef>
-        </p:style>
-        <p:txBody>
-          <a:bodyPr rtlCol="0" anchor="ctr" wrap="square" lIns="109728" rIns="109728" tIns="91440" bIns="91440"/>
-          <a:lstStyle/>
-          <a:p>
-            <a:pPr algn="ctr">
-              <a:spcBef>
-                <a:spcPts val="0"/>
-              </a:spcBef>
-              <a:spcAft>
-                <a:spcPts val="200"/>
-              </a:spcAft>
-              <a:buNone/>
-            </a:pPr>
-            <a:r>
-              <a:rPr b="1" sz="1050">
-                <a:solidFill>
-                  <a:srgbClr val="059669"/>
-                </a:solidFill>
-                <a:latin typeface="Calibri"/>
-              </a:rPr>
-              <a:t>VIABILITY &amp; NATIONAL SCALABILITY</a:t>
-            </a:r>
-          </a:p>
-          <a:p>
-            <a:pPr>
-              <a:spcBef>
-                <a:spcPts val="100"/>
-              </a:spcBef>
-              <a:spcAft>
-                <a:spcPts val="200"/>
-              </a:spcAft>
-            </a:pPr>
-            <a:r>
-              <a:rPr b="1" u="none" sz="850">
-                <a:solidFill>
-                  <a:srgbClr val="0A2540"/>
-                </a:solidFill>
-                <a:latin typeface="Calibri"/>
-              </a:rPr>
-              <a:t>Market Need : </a:t>
-            </a:r>
-            <a:r>
-              <a:rPr sz="850">
-                <a:solidFill>
-                  <a:srgbClr val="1E293B"/>
-                </a:solidFill>
-                <a:latin typeface="Calibri"/>
-              </a:rPr>
-              <a:t>India is the diabetes capital with 101M diabetics + 136M pre-diabetics; CVD accounts for 28.1% of all deaths; massive unaddressed preventive screening gap.</a:t>
-            </a:r>
-          </a:p>
-          <a:p>
-            <a:pPr>
-              <a:spcBef>
-                <a:spcPts val="100"/>
-              </a:spcBef>
-              <a:spcAft>
-                <a:spcPts val="200"/>
-              </a:spcAft>
-            </a:pPr>
-            <a:r>
-              <a:rPr b="1" u="none" sz="850">
-                <a:solidFill>
-                  <a:srgbClr val="0A2540"/>
-                </a:solidFill>
-                <a:latin typeface="Calibri"/>
-              </a:rPr>
-              <a:t>Policy Alignment : </a:t>
-            </a:r>
-            <a:r>
-              <a:rPr sz="850">
-                <a:solidFill>
-                  <a:srgbClr val="1E293B"/>
-                </a:solidFill>
-                <a:latin typeface="Calibri"/>
-              </a:rPr>
-              <a:t>Directly supports Ayushman Bharat (ABDM), National Health Mission (NHM), and Digital India healthcare interoperability standards.</a:t>
-            </a:r>
-          </a:p>
-          <a:p>
-            <a:pPr>
-              <a:spcBef>
-                <a:spcPts val="100"/>
-              </a:spcBef>
-              <a:spcAft>
-                <a:spcPts val="200"/>
-              </a:spcAft>
-            </a:pPr>
-            <a:r>
-              <a:rPr b="1" u="none" sz="850">
-                <a:solidFill>
-                  <a:srgbClr val="0A2540"/>
-                </a:solidFill>
-                <a:latin typeface="Calibri"/>
-              </a:rPr>
-              <a:t>Healthcare ROI : </a:t>
-            </a:r>
-            <a:r>
-              <a:rPr sz="850">
-                <a:solidFill>
-                  <a:srgbClr val="1E293B"/>
-                </a:solidFill>
-                <a:latin typeface="Calibri"/>
-              </a:rPr>
-              <a:t>40%–60% reduction in catastrophic household out-of-pocket medical expenditure by halting progression before dialysis or heart failure.</a:t>
-            </a:r>
-          </a:p>
-          <a:p>
-            <a:pPr>
-              <a:spcBef>
-                <a:spcPts val="100"/>
-              </a:spcBef>
-              <a:spcAft>
-                <a:spcPts val="200"/>
-              </a:spcAft>
-            </a:pPr>
-            <a:r>
-              <a:rPr b="1" u="none" sz="850">
-                <a:solidFill>
-                  <a:srgbClr val="0A2540"/>
-                </a:solidFill>
-                <a:latin typeface="Calibri"/>
-              </a:rPr>
-              <a:t>National Scale : </a:t>
-            </a:r>
-            <a:r>
-              <a:rPr sz="850">
-                <a:solidFill>
-                  <a:srgbClr val="1E293B"/>
-                </a:solidFill>
-                <a:latin typeface="Calibri"/>
-              </a:rPr>
-              <a:t>Ready for rapid integration into 24,000+ Primary Health Centres and 1.5 Lakh Ayushman Arogya Mandirs via 1-click batch triage.</a:t>
-            </a:r>
-          </a:p>
-          <a:p>
-            <a:pPr>
-              <a:spcBef>
-                <a:spcPts val="100"/>
-              </a:spcBef>
-              <a:spcAft>
-                <a:spcPts val="200"/>
-              </a:spcAft>
-            </a:pPr>
-            <a:r>
-              <a:rPr b="1" u="none" sz="850">
-                <a:solidFill>
-                  <a:srgbClr val="0A2540"/>
-                </a:solidFill>
-                <a:latin typeface="Calibri"/>
-              </a:rPr>
-              <a:t>Sustainable Rollout : </a:t>
-            </a:r>
-            <a:r>
-              <a:rPr sz="850">
-                <a:solidFill>
-                  <a:srgbClr val="1E293B"/>
-                </a:solidFill>
-                <a:latin typeface="Calibri"/>
-              </a:rPr>
-              <a:t>Self-sustaining public health deployment model with modular disease add-ons (kidney, oncology, cardiac).</a:t>
-            </a:r>
-          </a:p>
-        </p:txBody>
-      </p:sp>
-      <p:sp>
-        <p:nvSpPr>
-          <p:cNvPr id="17413" name="Rounded Rectangle 17412"/>
-          <p:cNvSpPr/>
-          <p:nvPr/>
-        </p:nvSpPr>
-        <p:spPr>
-          <a:xfrm>
-            <a:off x="685800" y="3931920"/>
-            <a:ext cx="5321808" cy="2057400"/>
-          </a:xfrm>
-          <a:prstGeom prst="roundRect">
-            <a:avLst/>
-          </a:prstGeom>
-          <a:solidFill>
-            <a:srgbClr val="FEF3C7"/>
-          </a:solidFill>
-          <a:ln w="19050">
-            <a:solidFill>
-              <a:srgbClr val="D97706"/>
-            </a:solidFill>
-          </a:ln>
-        </p:spPr>
-        <p:style>
-          <a:lnRef idx="1">
-            <a:schemeClr val="accent1"/>
-          </a:lnRef>
-          <a:fillRef idx="3">
-            <a:schemeClr val="accent1"/>
-          </a:fillRef>
-          <a:effectRef idx="2">
-            <a:schemeClr val="accent1"/>
-          </a:effectRef>
-          <a:fontRef idx="minor">
-            <a:schemeClr val="lt1"/>
-          </a:fontRef>
-        </p:style>
-        <p:txBody>
-          <a:bodyPr rtlCol="0" anchor="ctr" wrap="square" lIns="109728" rIns="109728" tIns="91440" bIns="91440"/>
-          <a:lstStyle/>
-          <a:p>
-            <a:pPr algn="ctr">
-              <a:spcBef>
-                <a:spcPts val="0"/>
-              </a:spcBef>
-              <a:spcAft>
-                <a:spcPts val="200"/>
-              </a:spcAft>
-              <a:buNone/>
-            </a:pPr>
-            <a:r>
-              <a:rPr b="1" sz="1000">
-                <a:solidFill>
-                  <a:srgbClr val="D97706"/>
-                </a:solidFill>
-                <a:latin typeface="Calibri"/>
-              </a:rPr>
-              <a:t>TECHNICAL CHALLENGES &amp; RISK MITIGATION</a:t>
-            </a:r>
-          </a:p>
-          <a:p>
-            <a:pPr>
-              <a:spcBef>
-                <a:spcPts val="100"/>
-              </a:spcBef>
-              <a:spcAft>
-                <a:spcPts val="200"/>
-              </a:spcAft>
-            </a:pPr>
-            <a:r>
-              <a:rPr b="1" u="none" sz="850">
-                <a:solidFill>
-                  <a:srgbClr val="D97706"/>
-                </a:solidFill>
-                <a:latin typeface="Calibri"/>
-              </a:rPr>
-              <a:t>Risk (NISQ Hardware Noise) : </a:t>
-            </a:r>
-            <a:r>
-              <a:rPr sz="850">
-                <a:solidFill>
-                  <a:srgbClr val="1E293B"/>
-                </a:solidFill>
-                <a:latin typeface="Calibri"/>
-              </a:rPr>
-              <a:t>Physical quantum processors suffer from gate errors and qubit decoherence.</a:t>
-            </a:r>
-          </a:p>
-          <a:p>
-            <a:pPr>
-              <a:spcBef>
-                <a:spcPts val="100"/>
-              </a:spcBef>
-              <a:spcAft>
-                <a:spcPts val="200"/>
-              </a:spcAft>
-            </a:pPr>
-            <a:r>
-              <a:rPr b="1" u="none" sz="850">
-                <a:solidFill>
-                  <a:srgbClr val="D97706"/>
-                </a:solidFill>
-                <a:latin typeface="Calibri"/>
-              </a:rPr>
-              <a:t>Mitigation (Noise Physics &amp; ZNE) : </a:t>
-            </a:r>
-            <a:r>
-              <a:rPr sz="850">
-                <a:solidFill>
-                  <a:srgbClr val="1E293B"/>
-                </a:solidFill>
-                <a:latin typeface="Calibri"/>
-              </a:rPr>
-              <a:t>Built-in depolarizing noise simulation (p=0.05) with Zero-Noise Extrapolation (ZNE) error mitigation and classical ensemble fallbacks.</a:t>
-            </a:r>
-          </a:p>
-          <a:p>
-            <a:pPr>
-              <a:spcBef>
-                <a:spcPts val="100"/>
-              </a:spcBef>
-              <a:spcAft>
-                <a:spcPts val="200"/>
-              </a:spcAft>
-            </a:pPr>
-            <a:r>
-              <a:rPr b="1" u="none" sz="850">
-                <a:solidFill>
-                  <a:srgbClr val="D97706"/>
-                </a:solidFill>
-                <a:latin typeface="Calibri"/>
-              </a:rPr>
-              <a:t>Risk (Barren Plateaus) : </a:t>
-            </a:r>
-            <a:r>
-              <a:rPr sz="850">
-                <a:solidFill>
-                  <a:srgbClr val="1E293B"/>
-                </a:solidFill>
-                <a:latin typeface="Calibri"/>
-              </a:rPr>
-              <a:t>Deep quantum circuits suffer from vanishing gradient landscapes during optimization.</a:t>
-            </a:r>
-          </a:p>
-          <a:p>
-            <a:pPr>
-              <a:spcBef>
-                <a:spcPts val="100"/>
-              </a:spcBef>
-              <a:spcAft>
-                <a:spcPts val="200"/>
-              </a:spcAft>
-            </a:pPr>
-            <a:r>
-              <a:rPr b="1" u="none" sz="850">
-                <a:solidFill>
-                  <a:srgbClr val="D97706"/>
-                </a:solidFill>
-                <a:latin typeface="Calibri"/>
-              </a:rPr>
-              <a:t>Mitigation (Shallow Ansatz) : </a:t>
-            </a:r>
-            <a:r>
-              <a:rPr sz="850">
-                <a:solidFill>
-                  <a:srgbClr val="1E293B"/>
-                </a:solidFill>
-                <a:latin typeface="Calibri"/>
-              </a:rPr>
-              <a:t>Strongly entangling layers restricted to depth &lt; 12 with localized CNOT ring topology.</a:t>
-            </a:r>
-          </a:p>
-        </p:txBody>
-      </p:sp>
-      <p:sp>
-        <p:nvSpPr>
-          <p:cNvPr id="17414" name="Rounded Rectangle 17413"/>
-          <p:cNvSpPr/>
-          <p:nvPr/>
-        </p:nvSpPr>
-        <p:spPr>
-          <a:xfrm>
-            <a:off x="6199632" y="3931920"/>
-            <a:ext cx="5321808" cy="2057400"/>
-          </a:xfrm>
-          <a:prstGeom prst="roundRect">
-            <a:avLst/>
-          </a:prstGeom>
-          <a:solidFill>
-            <a:srgbClr val="FFF1F2"/>
-          </a:solidFill>
-          <a:ln w="19050">
-            <a:solidFill>
-              <a:srgbClr val="E11D48"/>
-            </a:solidFill>
-          </a:ln>
-        </p:spPr>
-        <p:style>
-          <a:lnRef idx="1">
-            <a:schemeClr val="accent1"/>
-          </a:lnRef>
-          <a:fillRef idx="3">
-            <a:schemeClr val="accent1"/>
-          </a:fillRef>
-          <a:effectRef idx="2">
-            <a:schemeClr val="accent1"/>
-          </a:effectRef>
-          <a:fontRef idx="minor">
-            <a:schemeClr val="lt1"/>
-          </a:fontRef>
-        </p:style>
-        <p:txBody>
-          <a:bodyPr rtlCol="0" anchor="ctr" wrap="square" lIns="109728" rIns="109728" tIns="91440" bIns="91440"/>
-          <a:lstStyle/>
-          <a:p>
-            <a:pPr algn="ctr">
-              <a:spcBef>
-                <a:spcPts val="0"/>
-              </a:spcBef>
-              <a:spcAft>
-                <a:spcPts val="200"/>
-              </a:spcAft>
-              <a:buNone/>
-            </a:pPr>
-            <a:r>
-              <a:rPr b="1" sz="1000">
-                <a:solidFill>
-                  <a:srgbClr val="E11D48"/>
-                </a:solidFill>
-                <a:latin typeface="Calibri"/>
-              </a:rPr>
-              <a:t>CLINICAL &amp; HEALTHCARE CHALLENGES &amp; MITIGATION</a:t>
-            </a:r>
-          </a:p>
-          <a:p>
-            <a:pPr>
-              <a:spcBef>
-                <a:spcPts val="100"/>
-              </a:spcBef>
-              <a:spcAft>
-                <a:spcPts val="200"/>
-              </a:spcAft>
-            </a:pPr>
-            <a:r>
-              <a:rPr b="1" u="none" sz="850">
-                <a:solidFill>
-                  <a:srgbClr val="E11D48"/>
-                </a:solidFill>
-                <a:latin typeface="Calibri"/>
-              </a:rPr>
-              <a:t>Risk (Black-Box Skepticism) : </a:t>
-            </a:r>
-            <a:r>
-              <a:rPr sz="850">
-                <a:solidFill>
-                  <a:srgbClr val="1E293B"/>
-                </a:solidFill>
-                <a:latin typeface="Calibri"/>
-              </a:rPr>
-              <a:t>Clinicians resist adopting AI models that cannot explain the biological rationale.</a:t>
-            </a:r>
-          </a:p>
-          <a:p>
-            <a:pPr>
-              <a:spcBef>
-                <a:spcPts val="100"/>
-              </a:spcBef>
-              <a:spcAft>
-                <a:spcPts val="200"/>
-              </a:spcAft>
-            </a:pPr>
-            <a:r>
-              <a:rPr b="1" u="none" sz="850">
-                <a:solidFill>
-                  <a:srgbClr val="E11D48"/>
-                </a:solidFill>
-                <a:latin typeface="Calibri"/>
-              </a:rPr>
-              <a:t>Mitigation (SHAP &amp; Confidence) : </a:t>
-            </a:r>
-            <a:r>
-              <a:rPr sz="850">
-                <a:solidFill>
-                  <a:srgbClr val="1E293B"/>
-                </a:solidFill>
-                <a:latin typeface="Calibri"/>
-              </a:rPr>
-              <a:t>Every inference provides local SHAP biomarker attributions, bootstrap confidence intervals, and qubit weightings.</a:t>
-            </a:r>
-          </a:p>
-          <a:p>
-            <a:pPr>
-              <a:spcBef>
-                <a:spcPts val="100"/>
-              </a:spcBef>
-              <a:spcAft>
-                <a:spcPts val="200"/>
-              </a:spcAft>
-            </a:pPr>
-            <a:r>
-              <a:rPr b="1" u="none" sz="850">
-                <a:solidFill>
-                  <a:srgbClr val="E11D48"/>
-                </a:solidFill>
-                <a:latin typeface="Calibri"/>
-              </a:rPr>
-              <a:t>Risk (AI Hallucination on Noise) : </a:t>
-            </a:r>
-            <a:r>
-              <a:rPr sz="850">
-                <a:solidFill>
-                  <a:srgbClr val="1E293B"/>
-                </a:solidFill>
-                <a:latin typeface="Calibri"/>
-              </a:rPr>
-              <a:t>Models guess blindly on sensor failure or unphysiological patient inputs (e.g. Glucose = 0).</a:t>
-            </a:r>
-          </a:p>
-          <a:p>
-            <a:pPr>
-              <a:spcBef>
-                <a:spcPts val="100"/>
-              </a:spcBef>
-              <a:spcAft>
-                <a:spcPts val="200"/>
-              </a:spcAft>
-            </a:pPr>
-            <a:r>
-              <a:rPr b="1" u="none" sz="850">
-                <a:solidFill>
-                  <a:srgbClr val="E11D48"/>
-                </a:solidFill>
-                <a:latin typeface="Calibri"/>
-              </a:rPr>
-              <a:t>Mitigation (Safety Abstention) : </a:t>
-            </a:r>
-            <a:r>
-              <a:rPr sz="850">
-                <a:solidFill>
-                  <a:srgbClr val="1E293B"/>
-                </a:solidFill>
-                <a:latin typeface="Calibri"/>
-              </a:rPr>
-              <a:t>Hardcoded sentinel guardrails immediately refuse prediction and mandate laboratory re-testing.</a:t>
-            </a:r>
-          </a:p>
-        </p:txBody>
-      </p:sp>
+      </p:pic>
     </p:spTree>
     <p:extLst>
       <p:ext uri="{BB962C8B-B14F-4D97-AF65-F5344CB8AC3E}">
@@ -9064,7 +8208,7 @@
                 </a:solidFill>
                 <a:latin typeface="Calibri"/>
               </a:rPr>
-              <a:t>MACRO HEALTHCARE &amp; SOCIO-ECONOMIC IMPACT</a:t>
+              <a:t>STAKEHOLDER TRANSFORMATION (PERSONAS &amp; REAL IMPACT)</a:t>
             </a:r>
           </a:p>
           <a:p>
@@ -9079,11 +8223,11 @@
             <a:r>
               <a:rPr b="1" u="none" sz="850">
                 <a:solidFill>
-                  <a:srgbClr val="0A2540"/>
-                </a:solidFill>
-                <a:latin typeface="Calibri"/>
-              </a:rPr>
-              <a:t>Economic &amp; Financial Impact : </a:t>
+                  <a:srgbClr val="1877F2"/>
+                </a:solidFill>
+                <a:latin typeface="Calibri"/>
+              </a:rPr>
+              <a:t>For OPD &amp; Primary Care Doctors : </a:t>
             </a:r>
             <a:r>
               <a:rPr sz="850">
@@ -9092,7 +8236,7 @@
                 </a:solidFill>
                 <a:latin typeface="Calibri"/>
               </a:rPr>
-              <a:t>Pre-symptomatic detection 3–5 years earlier prevents end-stage renal failure and bypass surgeries, saving Indian families ₹50,000+ crore in out-of-pocket expenses.</a:t>
+              <a:t>Instant 1.1s calibrated second opinion with SHAP biomarker attributions, eliminating diagnostic delay and clinical guessing.</a:t>
             </a:r>
           </a:p>
           <a:p>
@@ -9107,11 +8251,11 @@
             <a:r>
               <a:rPr b="1" u="none" sz="850">
                 <a:solidFill>
-                  <a:srgbClr val="0A2540"/>
-                </a:solidFill>
-                <a:latin typeface="Calibri"/>
-              </a:rPr>
-              <a:t>Public Health &amp; Environmental : </a:t>
+                  <a:srgbClr val="D97706"/>
+                </a:solidFill>
+                <a:latin typeface="Calibri"/>
+              </a:rPr>
+              <a:t>For ASHA &amp; ANM Field Workers : </a:t>
             </a:r>
             <a:r>
               <a:rPr sz="850">
@@ -9120,7 +8264,7 @@
                 </a:solidFill>
                 <a:latin typeface="Calibri"/>
               </a:rPr>
-              <a:t>Non-invasive multi-biomarker screening eliminates redundant invasive lab biopsies, conserving chemical reagents and reducing patient travel emissions.</a:t>
+              <a:t>1-click batch triage for village screening camps (500 records in 12s), exporting prioritized follow-up rosters without internet.</a:t>
             </a:r>
           </a:p>
           <a:p>
@@ -9135,20 +8279,48 @@
             <a:r>
               <a:rPr b="1" u="none" sz="850">
                 <a:solidFill>
+                  <a:srgbClr val="059669"/>
+                </a:solidFill>
+                <a:latin typeface="Calibri"/>
+              </a:rPr>
+              <a:t>For National Health Mission &amp; India : </a:t>
+            </a:r>
+            <a:r>
+              <a:rPr sz="850">
+                <a:solidFill>
+                  <a:srgbClr val="1E293B"/>
+                </a:solidFill>
+                <a:latin typeface="Calibri"/>
+              </a:rPr>
+              <a:t>40%–60% reduction in catastrophic OOP spending, ₹50,000 Cr national savings, full ABDM digital health compliance.</a:t>
+            </a:r>
+          </a:p>
+          <a:p>
+            <a:pPr>
+              <a:spcBef>
+                <a:spcPts val="100"/>
+              </a:spcBef>
+              <a:spcAft>
+                <a:spcPts val="200"/>
+              </a:spcAft>
+            </a:pPr>
+            <a:r>
+              <a:rPr b="1" u="none" sz="819">
+                <a:solidFill>
                   <a:srgbClr val="0A2540"/>
                 </a:solidFill>
                 <a:latin typeface="Calibri"/>
               </a:rPr>
-              <a:t>Social &amp; Healthcare Equity : </a:t>
-            </a:r>
-            <a:r>
-              <a:rPr sz="850">
+              <a:t>Core Breakthrough Metrics : </a:t>
+            </a:r>
+            <a:r>
+              <a:rPr sz="819">
                 <a:solidFill>
                   <a:srgbClr val="1E293B"/>
                 </a:solidFill>
                 <a:latin typeface="Calibri"/>
               </a:rPr>
-              <a:t>Brings tertiary-level specialist diagnostic second opinions to remote North-Eastern &amp; rural districts (e.g. Nagaland), empowering ASHA workers and doctors.</a:t>
+              <a:t>3–5 Years Pre-Symptomatic Detection  •  40%–60% OOP Savings  •  100% Audit-Proof</a:t>
             </a:r>
           </a:p>
         </p:txBody>
@@ -10839,7 +10011,7 @@
       </p:sp>
       <p:pic>
         <p:nvPicPr>
-          <p:cNvPr id="17415" name="Picture 17414" descr="clinical_dashboard.jpg"/>
+          <p:cNvPr id="17415" name="Picture 17414" descr="ui_mockups_slide6.png"/>
           <p:cNvPicPr>
             <a:picLocks noChangeAspect="1"/>
           </p:cNvPicPr>
@@ -10854,31 +10026,7 @@
         <p:spPr>
           <a:xfrm>
             <a:off x="6812280" y="4754880"/>
-            <a:ext cx="2286000" cy="1691640"/>
-          </a:xfrm>
-          <a:prstGeom prst="rect">
-            <a:avLst/>
-          </a:prstGeom>
-        </p:spPr>
-      </p:pic>
-      <p:pic>
-        <p:nvPicPr>
-          <p:cNvPr id="17416" name="Picture 17415" descr="quantum_core.jpg"/>
-          <p:cNvPicPr>
-            <a:picLocks noChangeAspect="1"/>
-          </p:cNvPicPr>
-          <p:nvPr/>
-        </p:nvPicPr>
-        <p:blipFill>
-          <a:blip r:embed="rId5"/>
-          <a:stretch>
-            <a:fillRect/>
-          </a:stretch>
-        </p:blipFill>
-        <p:spPr>
-          <a:xfrm>
-            <a:off x="9235440" y="4754880"/>
-            <a:ext cx="2286000" cy="1691640"/>
+            <a:ext cx="4709160" cy="1691640"/>
           </a:xfrm>
           <a:prstGeom prst="rect">
             <a:avLst/>

</xml_diff>